<commit_message>
Product- Working with product update (part - 1)
</commit_message>
<xml_diff>
--- a/.lessons/58 Backend Product And Related Features/14 Product- Working with product update (part - 1)/1.pptx
+++ b/.lessons/58 Backend Product And Related Features/14 Product- Working with product update (part - 1)/1.pptx
@@ -7,7 +7,10 @@
   <p:sldIdLst>
     <p:sldId id="413" r:id="rId2"/>
     <p:sldId id="414" r:id="rId3"/>
-    <p:sldId id="400" r:id="rId4"/>
+    <p:sldId id="415" r:id="rId4"/>
+    <p:sldId id="416" r:id="rId5"/>
+    <p:sldId id="417" r:id="rId6"/>
+    <p:sldId id="400" r:id="rId7"/>
   </p:sldIdLst>
   <p:sldSz cx="12192000" cy="6858000"/>
   <p:notesSz cx="6858000" cy="9144000"/>
@@ -261,7 +264,7 @@
           <a:p>
             <a:fld id="{3E102D2E-813C-461C-9963-687A650C48C0}" type="datetimeFigureOut">
               <a:rPr lang="en-US" smtClean="0"/>
-              <a:t>6/26/2025</a:t>
+              <a:t>10/7/2025</a:t>
             </a:fld>
             <a:endParaRPr lang="en-US"/>
           </a:p>
@@ -459,7 +462,7 @@
           <a:p>
             <a:fld id="{3E102D2E-813C-461C-9963-687A650C48C0}" type="datetimeFigureOut">
               <a:rPr lang="en-US" smtClean="0"/>
-              <a:t>6/26/2025</a:t>
+              <a:t>10/7/2025</a:t>
             </a:fld>
             <a:endParaRPr lang="en-US"/>
           </a:p>
@@ -667,7 +670,7 @@
           <a:p>
             <a:fld id="{3E102D2E-813C-461C-9963-687A650C48C0}" type="datetimeFigureOut">
               <a:rPr lang="en-US" smtClean="0"/>
-              <a:t>6/26/2025</a:t>
+              <a:t>10/7/2025</a:t>
             </a:fld>
             <a:endParaRPr lang="en-US"/>
           </a:p>
@@ -865,7 +868,7 @@
           <a:p>
             <a:fld id="{3E102D2E-813C-461C-9963-687A650C48C0}" type="datetimeFigureOut">
               <a:rPr lang="en-US" smtClean="0"/>
-              <a:t>6/26/2025</a:t>
+              <a:t>10/7/2025</a:t>
             </a:fld>
             <a:endParaRPr lang="en-US"/>
           </a:p>
@@ -1140,7 +1143,7 @@
           <a:p>
             <a:fld id="{3E102D2E-813C-461C-9963-687A650C48C0}" type="datetimeFigureOut">
               <a:rPr lang="en-US" smtClean="0"/>
-              <a:t>6/26/2025</a:t>
+              <a:t>10/7/2025</a:t>
             </a:fld>
             <a:endParaRPr lang="en-US"/>
           </a:p>
@@ -1405,7 +1408,7 @@
           <a:p>
             <a:fld id="{3E102D2E-813C-461C-9963-687A650C48C0}" type="datetimeFigureOut">
               <a:rPr lang="en-US" smtClean="0"/>
-              <a:t>6/26/2025</a:t>
+              <a:t>10/7/2025</a:t>
             </a:fld>
             <a:endParaRPr lang="en-US"/>
           </a:p>
@@ -1817,7 +1820,7 @@
           <a:p>
             <a:fld id="{3E102D2E-813C-461C-9963-687A650C48C0}" type="datetimeFigureOut">
               <a:rPr lang="en-US" smtClean="0"/>
-              <a:t>6/26/2025</a:t>
+              <a:t>10/7/2025</a:t>
             </a:fld>
             <a:endParaRPr lang="en-US"/>
           </a:p>
@@ -1958,7 +1961,7 @@
           <a:p>
             <a:fld id="{3E102D2E-813C-461C-9963-687A650C48C0}" type="datetimeFigureOut">
               <a:rPr lang="en-US" smtClean="0"/>
-              <a:t>6/26/2025</a:t>
+              <a:t>10/7/2025</a:t>
             </a:fld>
             <a:endParaRPr lang="en-US"/>
           </a:p>
@@ -2071,7 +2074,7 @@
           <a:p>
             <a:fld id="{3E102D2E-813C-461C-9963-687A650C48C0}" type="datetimeFigureOut">
               <a:rPr lang="en-US" smtClean="0"/>
-              <a:t>6/26/2025</a:t>
+              <a:t>10/7/2025</a:t>
             </a:fld>
             <a:endParaRPr lang="en-US"/>
           </a:p>
@@ -2382,7 +2385,7 @@
           <a:p>
             <a:fld id="{3E102D2E-813C-461C-9963-687A650C48C0}" type="datetimeFigureOut">
               <a:rPr lang="en-US" smtClean="0"/>
-              <a:t>6/26/2025</a:t>
+              <a:t>10/7/2025</a:t>
             </a:fld>
             <a:endParaRPr lang="en-US"/>
           </a:p>
@@ -2670,7 +2673,7 @@
           <a:p>
             <a:fld id="{3E102D2E-813C-461C-9963-687A650C48C0}" type="datetimeFigureOut">
               <a:rPr lang="en-US" smtClean="0"/>
-              <a:t>6/26/2025</a:t>
+              <a:t>10/7/2025</a:t>
             </a:fld>
             <a:endParaRPr lang="en-US"/>
           </a:p>
@@ -2911,7 +2914,7 @@
           <a:p>
             <a:fld id="{3E102D2E-813C-461C-9963-687A650C48C0}" type="datetimeFigureOut">
               <a:rPr lang="en-US" smtClean="0"/>
-              <a:t>6/26/2025</a:t>
+              <a:t>10/7/2025</a:t>
             </a:fld>
             <a:endParaRPr lang="en-US"/>
           </a:p>
@@ -3348,8 +3351,8 @@
         </p:nvSpPr>
         <p:spPr>
           <a:xfrm>
-            <a:off x="217714" y="255046"/>
-            <a:ext cx="11756571" cy="355354"/>
+            <a:off x="0" y="255046"/>
+            <a:ext cx="12192000" cy="1255600"/>
           </a:xfrm>
           <a:prstGeom prst="rect">
             <a:avLst/>
@@ -3369,21 +3372,128 @@
               <a:buNone/>
             </a:pPr>
             <a:r>
-              <a:rPr kumimoji="0" lang="en-US" altLang="en-US" sz="1300" b="0" i="0" u="none" strike="noStrike" cap="none" normalizeH="0" baseline="0">
-                <a:ln>
-                  <a:noFill/>
-                </a:ln>
-                <a:solidFill>
-                  <a:schemeClr val="tx1"/>
-                </a:solidFill>
-                <a:effectLst/>
+              <a:rPr lang="az-Latn-AZ" altLang="en-US" sz="1300">
                 <a:latin typeface="Arial" panose="020B0604020202020204" pitchFamily="34" charset="0"/>
               </a:rPr>
-              <a:t>.</a:t>
-            </a:r>
-          </a:p>
-        </p:txBody>
-      </p:sp>
+              <a:t>Bu dərsə başlamadan əvvəl belə bir səhfv var ki, </a:t>
+            </a:r>
+            <a:r>
+              <a:rPr lang="az-Latn-AZ" altLang="en-US" sz="1300" b="1">
+                <a:latin typeface="Arial" panose="020B0604020202020204" pitchFamily="34" charset="0"/>
+              </a:rPr>
+              <a:t>Kateqori </a:t>
+            </a:r>
+            <a:r>
+              <a:rPr lang="en-US" altLang="en-US" sz="1300" b="1">
+                <a:latin typeface="Arial" panose="020B0604020202020204" pitchFamily="34" charset="0"/>
+              </a:rPr>
+              <a:t>-&gt; sub kateqori -&gt; child kateqory </a:t>
+            </a:r>
+            <a:r>
+              <a:rPr lang="az-Latn-AZ" altLang="en-US" sz="1300">
+                <a:latin typeface="Arial" panose="020B0604020202020204" pitchFamily="34" charset="0"/>
+              </a:rPr>
+              <a:t>seçdikdən sonra, başqa </a:t>
+            </a:r>
+            <a:r>
+              <a:rPr lang="az-Latn-AZ" altLang="en-US" sz="1300" b="1">
+                <a:latin typeface="Arial" panose="020B0604020202020204" pitchFamily="34" charset="0"/>
+              </a:rPr>
+              <a:t>kateqori</a:t>
+            </a:r>
+            <a:r>
+              <a:rPr lang="az-Latn-AZ" altLang="en-US" sz="1300">
+                <a:latin typeface="Arial" panose="020B0604020202020204" pitchFamily="34" charset="0"/>
+              </a:rPr>
+              <a:t> seçdikdə </a:t>
+            </a:r>
+            <a:r>
+              <a:rPr lang="az-Latn-AZ" altLang="en-US" sz="1300" b="1">
+                <a:latin typeface="Arial" panose="020B0604020202020204" pitchFamily="34" charset="0"/>
+              </a:rPr>
+              <a:t>child kateqori </a:t>
+            </a:r>
+            <a:r>
+              <a:rPr lang="az-Latn-AZ" altLang="en-US" sz="1300">
+                <a:latin typeface="Arial" panose="020B0604020202020204" pitchFamily="34" charset="0"/>
+              </a:rPr>
+              <a:t>olduğu kimi qalır. </a:t>
+            </a:r>
+          </a:p>
+          <a:p>
+            <a:pPr>
+              <a:lnSpc>
+                <a:spcPct val="150000"/>
+              </a:lnSpc>
+              <a:buNone/>
+            </a:pPr>
+            <a:endParaRPr kumimoji="0" lang="az-Latn-AZ" altLang="en-US" sz="1300" b="0" i="0" u="none" strike="noStrike" cap="none" normalizeH="0" baseline="0">
+              <a:ln>
+                <a:noFill/>
+              </a:ln>
+              <a:solidFill>
+                <a:schemeClr val="tx1"/>
+              </a:solidFill>
+              <a:effectLst/>
+              <a:latin typeface="Arial" panose="020B0604020202020204" pitchFamily="34" charset="0"/>
+            </a:endParaRPr>
+          </a:p>
+          <a:p>
+            <a:pPr>
+              <a:lnSpc>
+                <a:spcPct val="150000"/>
+              </a:lnSpc>
+              <a:buNone/>
+            </a:pPr>
+            <a:r>
+              <a:rPr lang="az-Latn-AZ" altLang="en-US" sz="1300">
+                <a:latin typeface="Arial" panose="020B0604020202020204" pitchFamily="34" charset="0"/>
+              </a:rPr>
+              <a:t>Bu create səhifəsində belədir onun üçün create səhifəsində düzəldək. Çünki edit səhifəsi create səhifəsinin kopyasıdır.</a:t>
+            </a:r>
+            <a:endParaRPr kumimoji="0" lang="en-US" altLang="en-US" sz="1300" b="0" i="0" u="none" strike="noStrike" cap="none" normalizeH="0" baseline="0">
+              <a:ln>
+                <a:noFill/>
+              </a:ln>
+              <a:solidFill>
+                <a:schemeClr val="tx1"/>
+              </a:solidFill>
+              <a:effectLst/>
+              <a:latin typeface="Arial" panose="020B0604020202020204" pitchFamily="34" charset="0"/>
+            </a:endParaRPr>
+          </a:p>
+        </p:txBody>
+      </p:sp>
+      <p:pic>
+        <p:nvPicPr>
+          <p:cNvPr id="4" name="Picture 3">
+            <a:extLst>
+              <a:ext uri="{FF2B5EF4-FFF2-40B4-BE49-F238E27FC236}">
+                <a16:creationId xmlns:a16="http://schemas.microsoft.com/office/drawing/2014/main" id="{FB49F581-1905-ACA9-656D-79DB663C8583}"/>
+              </a:ext>
+            </a:extLst>
+          </p:cNvPr>
+          <p:cNvPicPr>
+            <a:picLocks noChangeAspect="1"/>
+          </p:cNvPicPr>
+          <p:nvPr/>
+        </p:nvPicPr>
+        <p:blipFill>
+          <a:blip r:embed="rId2"/>
+          <a:stretch>
+            <a:fillRect/>
+          </a:stretch>
+        </p:blipFill>
+        <p:spPr>
+          <a:xfrm>
+            <a:off x="0" y="2880829"/>
+            <a:ext cx="12192000" cy="3977171"/>
+          </a:xfrm>
+          <a:prstGeom prst="rect">
+            <a:avLst/>
+          </a:prstGeom>
+        </p:spPr>
+      </p:pic>
     </p:spTree>
     <p:extLst>
       <p:ext uri="{BB962C8B-B14F-4D97-AF65-F5344CB8AC3E}">
@@ -3435,7 +3545,7 @@
         <p:spPr>
           <a:xfrm>
             <a:off x="217714" y="255046"/>
-            <a:ext cx="11756571" cy="355354"/>
+            <a:ext cx="11756571" cy="955518"/>
           </a:xfrm>
           <a:prstGeom prst="rect">
             <a:avLst/>
@@ -3455,7 +3565,42 @@
               <a:buNone/>
             </a:pPr>
             <a:r>
-              <a:rPr kumimoji="0" lang="en-US" altLang="en-US" sz="1300" b="0" i="0" u="none" strike="noStrike" cap="none" normalizeH="0" baseline="0">
+              <a:rPr lang="en-US" altLang="en-US" sz="1300">
+                <a:latin typeface="Arial" panose="020B0604020202020204" pitchFamily="34" charset="0"/>
+              </a:rPr>
+              <a:t>resources\views\admin\product\create.blade.php</a:t>
+            </a:r>
+            <a:endParaRPr lang="az-Latn-AZ" altLang="en-US" sz="1300">
+              <a:latin typeface="Arial" panose="020B0604020202020204" pitchFamily="34" charset="0"/>
+            </a:endParaRPr>
+          </a:p>
+          <a:p>
+            <a:pPr>
+              <a:lnSpc>
+                <a:spcPct val="150000"/>
+              </a:lnSpc>
+              <a:buNone/>
+            </a:pPr>
+            <a:endParaRPr kumimoji="0" lang="az-Latn-AZ" altLang="en-US" sz="1300" b="0" i="0" u="none" strike="noStrike" cap="none" normalizeH="0" baseline="0">
+              <a:ln>
+                <a:noFill/>
+              </a:ln>
+              <a:solidFill>
+                <a:schemeClr val="tx1"/>
+              </a:solidFill>
+              <a:effectLst/>
+              <a:latin typeface="Arial" panose="020B0604020202020204" pitchFamily="34" charset="0"/>
+            </a:endParaRPr>
+          </a:p>
+          <a:p>
+            <a:pPr>
+              <a:lnSpc>
+                <a:spcPct val="150000"/>
+              </a:lnSpc>
+              <a:buNone/>
+            </a:pPr>
+            <a:r>
+              <a:rPr kumimoji="0" lang="az-Latn-AZ" altLang="en-US" sz="1300" b="0" i="0" u="none" strike="noStrike" cap="none" normalizeH="0" baseline="0">
                 <a:ln>
                   <a:noFill/>
                 </a:ln>
@@ -3465,11 +3610,51 @@
                 <a:effectLst/>
                 <a:latin typeface="Arial" panose="020B0604020202020204" pitchFamily="34" charset="0"/>
               </a:rPr>
-              <a:t>.</a:t>
-            </a:r>
-          </a:p>
-        </p:txBody>
-      </p:sp>
+              <a:t>Burada şəkildəki kimi əlavə etmək lazımdır.</a:t>
+            </a:r>
+            <a:endParaRPr kumimoji="0" lang="en-US" altLang="en-US" sz="1300" b="0" i="0" u="none" strike="noStrike" cap="none" normalizeH="0" baseline="0">
+              <a:ln>
+                <a:noFill/>
+              </a:ln>
+              <a:solidFill>
+                <a:schemeClr val="tx1"/>
+              </a:solidFill>
+              <a:effectLst/>
+              <a:latin typeface="Arial" panose="020B0604020202020204" pitchFamily="34" charset="0"/>
+            </a:endParaRPr>
+          </a:p>
+        </p:txBody>
+      </p:sp>
+      <p:pic>
+        <p:nvPicPr>
+          <p:cNvPr id="4" name="Picture 3">
+            <a:extLst>
+              <a:ext uri="{FF2B5EF4-FFF2-40B4-BE49-F238E27FC236}">
+                <a16:creationId xmlns:a16="http://schemas.microsoft.com/office/drawing/2014/main" id="{B169E0D7-DB29-F643-A68C-9B5A9CBC5F0A}"/>
+              </a:ext>
+            </a:extLst>
+          </p:cNvPr>
+          <p:cNvPicPr>
+            <a:picLocks noChangeAspect="1"/>
+          </p:cNvPicPr>
+          <p:nvPr/>
+        </p:nvPicPr>
+        <p:blipFill>
+          <a:blip r:embed="rId2"/>
+          <a:stretch>
+            <a:fillRect/>
+          </a:stretch>
+        </p:blipFill>
+        <p:spPr>
+          <a:xfrm>
+            <a:off x="6424246" y="0"/>
+            <a:ext cx="5767754" cy="6858000"/>
+          </a:xfrm>
+          <a:prstGeom prst="rect">
+            <a:avLst/>
+          </a:prstGeom>
+        </p:spPr>
+      </p:pic>
     </p:spTree>
     <p:extLst>
       <p:ext uri="{BB962C8B-B14F-4D97-AF65-F5344CB8AC3E}">
@@ -3484,6 +3669,399 @@
 </file>
 
 <file path=ppt/slides/slide3.xml><?xml version="1.0" encoding="utf-8"?>
+<p:sld xmlns:a="http://schemas.openxmlformats.org/drawingml/2006/main" xmlns:r="http://schemas.openxmlformats.org/officeDocument/2006/relationships" xmlns:p="http://schemas.openxmlformats.org/presentationml/2006/main">
+  <p:cSld>
+    <p:spTree>
+      <p:nvGrpSpPr>
+        <p:cNvPr id="1" name="">
+          <a:extLst>
+            <a:ext uri="{FF2B5EF4-FFF2-40B4-BE49-F238E27FC236}">
+              <a16:creationId xmlns:a16="http://schemas.microsoft.com/office/drawing/2014/main" id="{B13A3C0F-7954-C93F-9D78-BD556291A734}"/>
+            </a:ext>
+          </a:extLst>
+        </p:cNvPr>
+        <p:cNvGrpSpPr/>
+        <p:nvPr/>
+      </p:nvGrpSpPr>
+      <p:grpSpPr>
+        <a:xfrm>
+          <a:off x="0" y="0"/>
+          <a:ext cx="0" cy="0"/>
+          <a:chOff x="0" y="0"/>
+          <a:chExt cx="0" cy="0"/>
+        </a:xfrm>
+      </p:grpSpPr>
+      <p:sp>
+        <p:nvSpPr>
+          <p:cNvPr id="3" name="TextBox 2">
+            <a:extLst>
+              <a:ext uri="{FF2B5EF4-FFF2-40B4-BE49-F238E27FC236}">
+                <a16:creationId xmlns:a16="http://schemas.microsoft.com/office/drawing/2014/main" id="{E18A3F31-4F7A-A698-31FE-43B912EB434D}"/>
+              </a:ext>
+            </a:extLst>
+          </p:cNvPr>
+          <p:cNvSpPr txBox="1"/>
+          <p:nvPr/>
+        </p:nvSpPr>
+        <p:spPr>
+          <a:xfrm>
+            <a:off x="217714" y="255046"/>
+            <a:ext cx="11756571" cy="1255600"/>
+          </a:xfrm>
+          <a:prstGeom prst="rect">
+            <a:avLst/>
+          </a:prstGeom>
+          <a:noFill/>
+        </p:spPr>
+        <p:txBody>
+          <a:bodyPr wrap="square">
+            <a:spAutoFit/>
+          </a:bodyPr>
+          <a:lstStyle/>
+          <a:p>
+            <a:pPr>
+              <a:lnSpc>
+                <a:spcPct val="150000"/>
+              </a:lnSpc>
+              <a:buNone/>
+            </a:pPr>
+            <a:r>
+              <a:rPr lang="en-US" altLang="en-US" sz="1300">
+                <a:latin typeface="Arial" panose="020B0604020202020204" pitchFamily="34" charset="0"/>
+              </a:rPr>
+              <a:t>resources\views\admin\product\edit.blade.php</a:t>
+            </a:r>
+            <a:endParaRPr lang="az-Latn-AZ" altLang="en-US" sz="1300">
+              <a:latin typeface="Arial" panose="020B0604020202020204" pitchFamily="34" charset="0"/>
+            </a:endParaRPr>
+          </a:p>
+          <a:p>
+            <a:pPr>
+              <a:lnSpc>
+                <a:spcPct val="150000"/>
+              </a:lnSpc>
+              <a:buNone/>
+            </a:pPr>
+            <a:endParaRPr kumimoji="0" lang="az-Latn-AZ" altLang="en-US" sz="1300" b="0" i="0" u="none" strike="noStrike" cap="none" normalizeH="0" baseline="0">
+              <a:ln>
+                <a:noFill/>
+              </a:ln>
+              <a:solidFill>
+                <a:schemeClr val="tx1"/>
+              </a:solidFill>
+              <a:effectLst/>
+              <a:latin typeface="Arial" panose="020B0604020202020204" pitchFamily="34" charset="0"/>
+            </a:endParaRPr>
+          </a:p>
+          <a:p>
+            <a:pPr>
+              <a:lnSpc>
+                <a:spcPct val="150000"/>
+              </a:lnSpc>
+              <a:buNone/>
+            </a:pPr>
+            <a:endParaRPr lang="az-Latn-AZ" altLang="en-US" sz="1300">
+              <a:latin typeface="Arial" panose="020B0604020202020204" pitchFamily="34" charset="0"/>
+            </a:endParaRPr>
+          </a:p>
+          <a:p>
+            <a:pPr>
+              <a:lnSpc>
+                <a:spcPct val="150000"/>
+              </a:lnSpc>
+              <a:buNone/>
+            </a:pPr>
+            <a:r>
+              <a:rPr kumimoji="0" lang="az-Latn-AZ" altLang="en-US" sz="1300" b="0" i="0" u="none" strike="noStrike" cap="none" normalizeH="0" baseline="0">
+                <a:ln>
+                  <a:noFill/>
+                </a:ln>
+                <a:solidFill>
+                  <a:schemeClr val="tx1"/>
+                </a:solidFill>
+                <a:effectLst/>
+                <a:latin typeface="Arial" panose="020B0604020202020204" pitchFamily="34" charset="0"/>
+              </a:rPr>
+              <a:t>İstəsəz kodları fayldan</a:t>
+            </a:r>
+            <a:r>
+              <a:rPr lang="az-Latn-AZ" altLang="en-US" sz="1300">
+                <a:latin typeface="Arial" panose="020B0604020202020204" pitchFamily="34" charset="0"/>
+              </a:rPr>
+              <a:t> </a:t>
+            </a:r>
+            <a:r>
+              <a:rPr kumimoji="0" lang="az-Latn-AZ" altLang="en-US" sz="1300" b="0" i="0" u="none" strike="noStrike" cap="none" normalizeH="0" baseline="0">
+                <a:ln>
+                  <a:noFill/>
+                </a:ln>
+                <a:solidFill>
+                  <a:schemeClr val="tx1"/>
+                </a:solidFill>
+                <a:effectLst/>
+                <a:latin typeface="Arial" panose="020B0604020202020204" pitchFamily="34" charset="0"/>
+              </a:rPr>
+              <a:t>götürə bilərsiz.</a:t>
+            </a:r>
+            <a:endParaRPr kumimoji="0" lang="en-US" altLang="en-US" sz="1300" b="0" i="0" u="none" strike="noStrike" cap="none" normalizeH="0" baseline="0">
+              <a:ln>
+                <a:noFill/>
+              </a:ln>
+              <a:solidFill>
+                <a:schemeClr val="tx1"/>
+              </a:solidFill>
+              <a:effectLst/>
+              <a:latin typeface="Arial" panose="020B0604020202020204" pitchFamily="34" charset="0"/>
+            </a:endParaRPr>
+          </a:p>
+        </p:txBody>
+      </p:sp>
+      <p:pic>
+        <p:nvPicPr>
+          <p:cNvPr id="4" name="Picture 3">
+            <a:extLst>
+              <a:ext uri="{FF2B5EF4-FFF2-40B4-BE49-F238E27FC236}">
+                <a16:creationId xmlns:a16="http://schemas.microsoft.com/office/drawing/2014/main" id="{B563C035-8B6A-B442-5D33-479260F7D95C}"/>
+              </a:ext>
+            </a:extLst>
+          </p:cNvPr>
+          <p:cNvPicPr>
+            <a:picLocks noChangeAspect="1"/>
+          </p:cNvPicPr>
+          <p:nvPr/>
+        </p:nvPicPr>
+        <p:blipFill>
+          <a:blip r:embed="rId2"/>
+          <a:stretch>
+            <a:fillRect/>
+          </a:stretch>
+        </p:blipFill>
+        <p:spPr>
+          <a:xfrm>
+            <a:off x="7260663" y="0"/>
+            <a:ext cx="4931337" cy="6858000"/>
+          </a:xfrm>
+          <a:prstGeom prst="rect">
+            <a:avLst/>
+          </a:prstGeom>
+        </p:spPr>
+      </p:pic>
+    </p:spTree>
+    <p:extLst>
+      <p:ext uri="{BB962C8B-B14F-4D97-AF65-F5344CB8AC3E}">
+        <p14:creationId xmlns:p14="http://schemas.microsoft.com/office/powerpoint/2010/main" val="3653018144"/>
+      </p:ext>
+    </p:extLst>
+  </p:cSld>
+  <p:clrMapOvr>
+    <a:masterClrMapping/>
+  </p:clrMapOvr>
+</p:sld>
+</file>
+
+<file path=ppt/slides/slide4.xml><?xml version="1.0" encoding="utf-8"?>
+<p:sld xmlns:a="http://schemas.openxmlformats.org/drawingml/2006/main" xmlns:r="http://schemas.openxmlformats.org/officeDocument/2006/relationships" xmlns:p="http://schemas.openxmlformats.org/presentationml/2006/main">
+  <p:cSld>
+    <p:spTree>
+      <p:nvGrpSpPr>
+        <p:cNvPr id="1" name="">
+          <a:extLst>
+            <a:ext uri="{FF2B5EF4-FFF2-40B4-BE49-F238E27FC236}">
+              <a16:creationId xmlns:a16="http://schemas.microsoft.com/office/drawing/2014/main" id="{7F1573C3-FB01-0C11-4E40-88271ED86CCF}"/>
+            </a:ext>
+          </a:extLst>
+        </p:cNvPr>
+        <p:cNvGrpSpPr/>
+        <p:nvPr/>
+      </p:nvGrpSpPr>
+      <p:grpSpPr>
+        <a:xfrm>
+          <a:off x="0" y="0"/>
+          <a:ext cx="0" cy="0"/>
+          <a:chOff x="0" y="0"/>
+          <a:chExt cx="0" cy="0"/>
+        </a:xfrm>
+      </p:grpSpPr>
+      <p:sp>
+        <p:nvSpPr>
+          <p:cNvPr id="3" name="TextBox 2">
+            <a:extLst>
+              <a:ext uri="{FF2B5EF4-FFF2-40B4-BE49-F238E27FC236}">
+                <a16:creationId xmlns:a16="http://schemas.microsoft.com/office/drawing/2014/main" id="{8DB704ED-15C1-33D2-9CB6-916A43DA71F4}"/>
+              </a:ext>
+            </a:extLst>
+          </p:cNvPr>
+          <p:cNvSpPr txBox="1"/>
+          <p:nvPr/>
+        </p:nvSpPr>
+        <p:spPr>
+          <a:xfrm>
+            <a:off x="217714" y="125737"/>
+            <a:ext cx="11756571" cy="355354"/>
+          </a:xfrm>
+          <a:prstGeom prst="rect">
+            <a:avLst/>
+          </a:prstGeom>
+          <a:noFill/>
+        </p:spPr>
+        <p:txBody>
+          <a:bodyPr wrap="square">
+            <a:spAutoFit/>
+          </a:bodyPr>
+          <a:lstStyle/>
+          <a:p>
+            <a:pPr>
+              <a:lnSpc>
+                <a:spcPct val="150000"/>
+              </a:lnSpc>
+              <a:buNone/>
+            </a:pPr>
+            <a:r>
+              <a:rPr kumimoji="0" lang="en-US" altLang="en-US" sz="1300" b="0" i="0" u="none" strike="noStrike" cap="none" normalizeH="0" baseline="0">
+                <a:ln>
+                  <a:noFill/>
+                </a:ln>
+                <a:solidFill>
+                  <a:schemeClr val="tx1"/>
+                </a:solidFill>
+                <a:effectLst/>
+                <a:latin typeface="Arial" panose="020B0604020202020204" pitchFamily="34" charset="0"/>
+              </a:rPr>
+              <a:t>.</a:t>
+            </a:r>
+          </a:p>
+        </p:txBody>
+      </p:sp>
+      <p:pic>
+        <p:nvPicPr>
+          <p:cNvPr id="4" name="Picture 3">
+            <a:extLst>
+              <a:ext uri="{FF2B5EF4-FFF2-40B4-BE49-F238E27FC236}">
+                <a16:creationId xmlns:a16="http://schemas.microsoft.com/office/drawing/2014/main" id="{38EC046B-D38F-8D62-ACB7-932F186FBF1A}"/>
+              </a:ext>
+            </a:extLst>
+          </p:cNvPr>
+          <p:cNvPicPr>
+            <a:picLocks noChangeAspect="1"/>
+          </p:cNvPicPr>
+          <p:nvPr/>
+        </p:nvPicPr>
+        <p:blipFill>
+          <a:blip r:embed="rId2"/>
+          <a:stretch>
+            <a:fillRect/>
+          </a:stretch>
+        </p:blipFill>
+        <p:spPr>
+          <a:xfrm>
+            <a:off x="0" y="587284"/>
+            <a:ext cx="12192000" cy="6270716"/>
+          </a:xfrm>
+          <a:prstGeom prst="rect">
+            <a:avLst/>
+          </a:prstGeom>
+        </p:spPr>
+      </p:pic>
+    </p:spTree>
+    <p:extLst>
+      <p:ext uri="{BB962C8B-B14F-4D97-AF65-F5344CB8AC3E}">
+        <p14:creationId xmlns:p14="http://schemas.microsoft.com/office/powerpoint/2010/main" val="1035231549"/>
+      </p:ext>
+    </p:extLst>
+  </p:cSld>
+  <p:clrMapOvr>
+    <a:masterClrMapping/>
+  </p:clrMapOvr>
+</p:sld>
+</file>
+
+<file path=ppt/slides/slide5.xml><?xml version="1.0" encoding="utf-8"?>
+<p:sld xmlns:a="http://schemas.openxmlformats.org/drawingml/2006/main" xmlns:r="http://schemas.openxmlformats.org/officeDocument/2006/relationships" xmlns:p="http://schemas.openxmlformats.org/presentationml/2006/main">
+  <p:cSld>
+    <p:spTree>
+      <p:nvGrpSpPr>
+        <p:cNvPr id="1" name="">
+          <a:extLst>
+            <a:ext uri="{FF2B5EF4-FFF2-40B4-BE49-F238E27FC236}">
+              <a16:creationId xmlns:a16="http://schemas.microsoft.com/office/drawing/2014/main" id="{9F74F916-7D33-A1F0-EAF6-19321898598D}"/>
+            </a:ext>
+          </a:extLst>
+        </p:cNvPr>
+        <p:cNvGrpSpPr/>
+        <p:nvPr/>
+      </p:nvGrpSpPr>
+      <p:grpSpPr>
+        <a:xfrm>
+          <a:off x="0" y="0"/>
+          <a:ext cx="0" cy="0"/>
+          <a:chOff x="0" y="0"/>
+          <a:chExt cx="0" cy="0"/>
+        </a:xfrm>
+      </p:grpSpPr>
+      <p:sp>
+        <p:nvSpPr>
+          <p:cNvPr id="3" name="TextBox 2">
+            <a:extLst>
+              <a:ext uri="{FF2B5EF4-FFF2-40B4-BE49-F238E27FC236}">
+                <a16:creationId xmlns:a16="http://schemas.microsoft.com/office/drawing/2014/main" id="{A7C06ABA-165E-3DE1-4A3A-F9493ED264F9}"/>
+              </a:ext>
+            </a:extLst>
+          </p:cNvPr>
+          <p:cNvSpPr txBox="1"/>
+          <p:nvPr/>
+        </p:nvSpPr>
+        <p:spPr>
+          <a:xfrm>
+            <a:off x="217714" y="255046"/>
+            <a:ext cx="11756571" cy="355354"/>
+          </a:xfrm>
+          <a:prstGeom prst="rect">
+            <a:avLst/>
+          </a:prstGeom>
+          <a:noFill/>
+        </p:spPr>
+        <p:txBody>
+          <a:bodyPr wrap="square">
+            <a:spAutoFit/>
+          </a:bodyPr>
+          <a:lstStyle/>
+          <a:p>
+            <a:pPr>
+              <a:lnSpc>
+                <a:spcPct val="150000"/>
+              </a:lnSpc>
+              <a:buNone/>
+            </a:pPr>
+            <a:r>
+              <a:rPr kumimoji="0" lang="en-US" altLang="en-US" sz="1300" b="0" i="0" u="none" strike="noStrike" cap="none" normalizeH="0" baseline="0">
+                <a:ln>
+                  <a:noFill/>
+                </a:ln>
+                <a:solidFill>
+                  <a:schemeClr val="tx1"/>
+                </a:solidFill>
+                <a:effectLst/>
+                <a:latin typeface="Arial" panose="020B0604020202020204" pitchFamily="34" charset="0"/>
+              </a:rPr>
+              <a:t>.</a:t>
+            </a:r>
+          </a:p>
+        </p:txBody>
+      </p:sp>
+    </p:spTree>
+    <p:extLst>
+      <p:ext uri="{BB962C8B-B14F-4D97-AF65-F5344CB8AC3E}">
+        <p14:creationId xmlns:p14="http://schemas.microsoft.com/office/powerpoint/2010/main" val="3673106325"/>
+      </p:ext>
+    </p:extLst>
+  </p:cSld>
+  <p:clrMapOvr>
+    <a:masterClrMapping/>
+  </p:clrMapOvr>
+</p:sld>
+</file>
+
+<file path=ppt/slides/slide6.xml><?xml version="1.0" encoding="utf-8"?>
 <p:sld xmlns:a="http://schemas.openxmlformats.org/drawingml/2006/main" xmlns:r="http://schemas.openxmlformats.org/officeDocument/2006/relationships" xmlns:p="http://schemas.openxmlformats.org/presentationml/2006/main">
   <p:cSld>
     <p:spTree>

</xml_diff>

<commit_message>
Product- Working with product update (part - 2)
</commit_message>
<xml_diff>
--- a/.lessons/58 Backend Product And Related Features/14 Product- Working with product update (part - 1)/1.pptx
+++ b/.lessons/58 Backend Product And Related Features/14 Product- Working with product update (part - 1)/1.pptx
@@ -3706,7 +3706,7 @@
         <p:spPr>
           <a:xfrm>
             <a:off x="217714" y="255046"/>
-            <a:ext cx="11756571" cy="1255600"/>
+            <a:ext cx="11756571" cy="1855764"/>
           </a:xfrm>
           <a:prstGeom prst="rect">
             <a:avLst/>
@@ -3802,6 +3802,38 @@
                 <a:latin typeface="Arial" panose="020B0604020202020204" pitchFamily="34" charset="0"/>
               </a:rPr>
               <a:t>götürə bilərsiz.</a:t>
+            </a:r>
+          </a:p>
+          <a:p>
+            <a:pPr>
+              <a:lnSpc>
+                <a:spcPct val="150000"/>
+              </a:lnSpc>
+              <a:buNone/>
+            </a:pPr>
+            <a:endParaRPr lang="az-Latn-AZ" altLang="en-US" sz="1300">
+              <a:latin typeface="Arial" panose="020B0604020202020204" pitchFamily="34" charset="0"/>
+            </a:endParaRPr>
+          </a:p>
+          <a:p>
+            <a:pPr>
+              <a:lnSpc>
+                <a:spcPct val="150000"/>
+              </a:lnSpc>
+              <a:buNone/>
+            </a:pPr>
+            <a:r>
+              <a:rPr kumimoji="0" lang="az-Latn-AZ" altLang="en-US" sz="1300" b="0" i="0" u="none" strike="noStrike" cap="none" normalizeH="0" baseline="0">
+                <a:ln>
+                  <a:noFill/>
+                </a:ln>
+                <a:solidFill>
+                  <a:schemeClr val="tx1"/>
+                </a:solidFill>
+                <a:effectLst/>
+                <a:latin typeface="Arial" panose="020B0604020202020204" pitchFamily="34" charset="0"/>
+              </a:rPr>
+              <a:t>Ancaq bəzi hissələri dəyişməyi unutmayın.</a:t>
             </a:r>
             <a:endParaRPr kumimoji="0" lang="en-US" altLang="en-US" sz="1300" b="0" i="0" u="none" strike="noStrike" cap="none" normalizeH="0" baseline="0">
               <a:ln>
@@ -3840,6 +3872,36 @@
           <a:xfrm>
             <a:off x="7260663" y="0"/>
             <a:ext cx="4931337" cy="6858000"/>
+          </a:xfrm>
+          <a:prstGeom prst="rect">
+            <a:avLst/>
+          </a:prstGeom>
+        </p:spPr>
+      </p:pic>
+      <p:pic>
+        <p:nvPicPr>
+          <p:cNvPr id="5" name="Picture 4">
+            <a:extLst>
+              <a:ext uri="{FF2B5EF4-FFF2-40B4-BE49-F238E27FC236}">
+                <a16:creationId xmlns:a16="http://schemas.microsoft.com/office/drawing/2014/main" id="{00139180-5D10-AAD8-32F3-66C07FF57B88}"/>
+              </a:ext>
+            </a:extLst>
+          </p:cNvPr>
+          <p:cNvPicPr>
+            <a:picLocks noChangeAspect="1"/>
+          </p:cNvPicPr>
+          <p:nvPr/>
+        </p:nvPicPr>
+        <p:blipFill>
+          <a:blip r:embed="rId3"/>
+          <a:stretch>
+            <a:fillRect/>
+          </a:stretch>
+        </p:blipFill>
+        <p:spPr>
+          <a:xfrm>
+            <a:off x="0" y="2216727"/>
+            <a:ext cx="5860572" cy="615430"/>
           </a:xfrm>
           <a:prstGeom prst="rect">
             <a:avLst/>

</xml_diff>